<commit_message>
feat(builder): add group= attribute for <p:grpSp> emission + raw-XML lint rule
- Any node tagged group="<id>" or group="true" rewrites into <p:grpSp> in the
  post-process pass, with nested groupings producing nested grpSp. Connectors
  riding inside a grouped subtree are pulled into the same grpSp so multi-
  element diagrams stay together when moved in PowerPoint.
- Add raw-XML lint rule (lint/rules/rawXml.ts) catching <p:...>/<a:...> tokens
  in attribute values that would otherwise pass through unrewritten.
- Refactor post-process sigil handling to share parse/strip routines between
  the cxnSp and groupSp passes, and strengthen object-name uniqueness.
- Regenerate codegen artifacts (schema / xsd / reference-html / xml-reference.md)
  and rebuild example decks exercising the new attribute.
</commit_message>
<xml_diff>
--- a/apps/web-playground/public/samples/01-pitch.pptx
+++ b/apps/web-playground/public/samples/01-pitch.pptx
@@ -4787,8 +4787,8 @@
         </p:nvSpPr>
         <p:spPr>
           <a:xfrm>
-            <a:off x="762000" y="2200275"/>
-            <a:ext cx="3000375" cy="133350"/>
+            <a:off x="762000" y="2219325"/>
+            <a:ext cx="3000375" cy="104775"/>
           </a:xfrm>
           <a:prstGeom prst="rect">
             <a:avLst/>
@@ -5850,8 +5850,8 @@
         </p:nvSpPr>
         <p:spPr>
           <a:xfrm>
-            <a:off x="6505575" y="2057400"/>
-            <a:ext cx="5153025" cy="190500"/>
+            <a:off x="6505575" y="2114550"/>
+            <a:ext cx="5153025" cy="133350"/>
           </a:xfrm>
           <a:prstGeom prst="rect">
             <a:avLst/>
@@ -6040,8 +6040,8 @@
         </p:nvSpPr>
         <p:spPr>
           <a:xfrm>
-            <a:off x="6505575" y="2762250"/>
-            <a:ext cx="5153025" cy="190500"/>
+            <a:off x="6505575" y="2819400"/>
+            <a:ext cx="5153025" cy="133350"/>
           </a:xfrm>
           <a:prstGeom prst="rect">
             <a:avLst/>
@@ -6230,8 +6230,8 @@
         </p:nvSpPr>
         <p:spPr>
           <a:xfrm>
-            <a:off x="6505575" y="3467100"/>
-            <a:ext cx="5153025" cy="190500"/>
+            <a:off x="6505575" y="3524250"/>
+            <a:ext cx="5153025" cy="133350"/>
           </a:xfrm>
           <a:prstGeom prst="rect">
             <a:avLst/>
@@ -6420,8 +6420,8 @@
         </p:nvSpPr>
         <p:spPr>
           <a:xfrm>
-            <a:off x="3962400" y="4629150"/>
-            <a:ext cx="2981325" cy="457200"/>
+            <a:off x="3962400" y="4781550"/>
+            <a:ext cx="2981325" cy="304800"/>
           </a:xfrm>
           <a:prstGeom prst="rect">
             <a:avLst/>

</xml_diff>